<commit_message>
Rename project to College Canteen Pre-Ordering App in College Canteen Pre-Ordering Review.pptx
Co-Authored-By: Claude Sonnet 5.5 <noreply@anthropic.com>
</commit_message>
<xml_diff>
--- a/College Canteen Pre-Ordering Review.pptx
+++ b/College Canteen Pre-Ordering Review.pptx
@@ -4144,7 +4144,7 @@
                 <a:ea typeface="Public Sans" pitchFamily="34" charset="-122"/>
                 <a:cs typeface="Public Sans" pitchFamily="34" charset="-120"/>
               </a:rPr>
-              <a:t>KLH Deemed to be University · College Canteen Pre-Ordering · SOA Project Review</a:t>
+              <a:t>KLH Deemed to be University · College Canteen Pre-Ordering App · SOA Project Review</a:t>
             </a:r>
             <a:endParaRPr lang="en-US" sz="1200" dirty="0"/>
           </a:p>
@@ -5674,7 +5674,7 @@
                 <a:ea typeface="Public Sans" pitchFamily="34" charset="-122"/>
                 <a:cs typeface="Public Sans" pitchFamily="34" charset="-120"/>
               </a:rPr>
-              <a:t>KLH Deemed to be University · College Canteen Pre-Ordering · SOA Project Review</a:t>
+              <a:t>KLH Deemed to be University · College Canteen Pre-Ordering App · SOA Project Review</a:t>
             </a:r>
             <a:endParaRPr lang="en-US" sz="1200" dirty="0"/>
           </a:p>
@@ -6414,7 +6414,7 @@
                 <a:ea typeface="Public Sans" pitchFamily="34" charset="-122"/>
                 <a:cs typeface="Public Sans" pitchFamily="34" charset="-120"/>
               </a:rPr>
-              <a:t>KLH Deemed to be University · College Canteen Pre-Ordering · SOA Project Review</a:t>
+              <a:t>KLH Deemed to be University · College Canteen Pre-Ordering App · SOA Project Review</a:t>
             </a:r>
             <a:endParaRPr lang="en-US" sz="1200" dirty="0"/>
           </a:p>
@@ -6988,7 +6988,7 @@
                 <a:ea typeface="Public Sans" pitchFamily="34" charset="-122"/>
                 <a:cs typeface="Public Sans" pitchFamily="34" charset="-120"/>
               </a:rPr>
-              <a:t>KLH Deemed to be University · College Canteen Pre-Ordering · SOA Project Review</a:t>
+              <a:t>KLH Deemed to be University · College Canteen Pre-Ordering App · SOA Project Review</a:t>
             </a:r>
             <a:endParaRPr lang="en-US" sz="1200" dirty="0"/>
           </a:p>
@@ -7840,7 +7840,7 @@
                 <a:ea typeface="Public Sans" pitchFamily="34" charset="-122"/>
                 <a:cs typeface="Public Sans" pitchFamily="34" charset="-120"/>
               </a:rPr>
-              <a:t>KLH Deemed to be University · College Canteen Pre-Ordering · SOA Project Review</a:t>
+              <a:t>KLH Deemed to be University · College Canteen Pre-Ordering App · SOA Project Review</a:t>
             </a:r>
             <a:endParaRPr lang="en-US" sz="1200" dirty="0"/>
           </a:p>
@@ -9764,7 +9764,7 @@
                 <a:ea typeface="Public Sans" pitchFamily="34" charset="-122"/>
                 <a:cs typeface="Public Sans" pitchFamily="34" charset="-120"/>
               </a:rPr>
-              <a:t>KLH Deemed to be University · College Canteen Pre-Ordering · SOA Project Review</a:t>
+              <a:t>KLH Deemed to be University · College Canteen Pre-Ordering App · SOA Project Review</a:t>
             </a:r>
             <a:endParaRPr lang="en-US" sz="1200" dirty="0"/>
           </a:p>
@@ -10978,7 +10978,7 @@
                 <a:ea typeface="Public Sans" pitchFamily="34" charset="-122"/>
                 <a:cs typeface="Public Sans" pitchFamily="34" charset="-120"/>
               </a:rPr>
-              <a:t>KLH Deemed to be University · College Canteen Pre-Ordering · SOA Project Review</a:t>
+              <a:t>KLH Deemed to be University · College Canteen Pre-Ordering App · SOA Project Review</a:t>
             </a:r>
             <a:endParaRPr lang="en-US" sz="1200" dirty="0"/>
           </a:p>
@@ -12565,7 +12565,7 @@
                 <a:ea typeface="Public Sans" pitchFamily="34" charset="-122"/>
                 <a:cs typeface="Public Sans" pitchFamily="34" charset="-120"/>
               </a:rPr>
-              <a:t>KLH Deemed to be University · College Canteen Pre-Ordering · SOA Project Review</a:t>
+              <a:t>KLH Deemed to be University · College Canteen Pre-Ordering App · SOA Project Review</a:t>
             </a:r>
             <a:endParaRPr lang="en-US" sz="1200" dirty="0"/>
           </a:p>
@@ -14345,7 +14345,7 @@
                 <a:ea typeface="Public Sans" pitchFamily="34" charset="-122"/>
                 <a:cs typeface="Public Sans" pitchFamily="34" charset="-120"/>
               </a:rPr>
-              <a:t>KLH Deemed to be University · College Canteen Pre-Ordering · SOA Project Review</a:t>
+              <a:t>KLH Deemed to be University · College Canteen Pre-Ordering App · SOA Project Review</a:t>
             </a:r>
             <a:endParaRPr lang="en-US" sz="1200" dirty="0"/>
           </a:p>
@@ -15924,7 +15924,7 @@
                 <a:ea typeface="Public Sans" pitchFamily="34" charset="-122"/>
                 <a:cs typeface="Public Sans" pitchFamily="34" charset="-120"/>
               </a:rPr>
-              <a:t>KLH Deemed to be University · College Canteen Pre-Ordering · SOA Project Review</a:t>
+              <a:t>KLH Deemed to be University · College Canteen Pre-Ordering App · SOA Project Review</a:t>
             </a:r>
             <a:endParaRPr lang="en-US" sz="1200" dirty="0"/>
           </a:p>
@@ -17045,7 +17045,7 @@
                 <a:ea typeface="Public Sans" pitchFamily="34" charset="-122"/>
                 <a:cs typeface="Public Sans" pitchFamily="34" charset="-120"/>
               </a:rPr>
-              <a:t>KLH Deemed to be University · College Canteen Pre-Ordering · SOA Project Review</a:t>
+              <a:t>KLH Deemed to be University · College Canteen Pre-Ordering App · SOA Project Review</a:t>
             </a:r>
             <a:endParaRPr lang="en-US" sz="1200" dirty="0"/>
           </a:p>
@@ -18115,7 +18115,7 @@
                 <a:ea typeface="Public Sans" pitchFamily="34" charset="-122"/>
                 <a:cs typeface="Public Sans" pitchFamily="34" charset="-120"/>
               </a:rPr>
-              <a:t>KLH Deemed to be University · College Canteen Pre-Ordering · SOA Project Review</a:t>
+              <a:t>KLH Deemed to be University · College Canteen Pre-Ordering App · SOA Project Review</a:t>
             </a:r>
             <a:endParaRPr lang="en-US" sz="1200" dirty="0"/>
           </a:p>
@@ -18173,9 +18173,9 @@
 </file>
 
 <file path=ppt/theme/theme1.xml><?xml version="1.0" encoding="utf-8"?>
-<a:theme xmlns:a="http://schemas.openxmlformats.org/drawingml/2006/main" name="College Canteen Pre-Ordering Review">
+<a:theme xmlns:a="http://schemas.openxmlformats.org/drawingml/2006/main" name="College Canteen Pre-Ordering App Review">
   <a:themeElements>
-    <a:clrScheme name="College Canteen Pre-Ordering Review">
+    <a:clrScheme name="College Canteen Pre-Ordering App Review">
       <a:dk1>
         <a:srgbClr val="1F2430"/>
       </a:dk1>
@@ -18213,7 +18213,7 @@
         <a:srgbClr val="954F72"/>
       </a:folHlink>
     </a:clrScheme>
-    <a:fontScheme name="College Canteen Pre-Ordering Review">
+    <a:fontScheme name="College Canteen Pre-Ordering App Review">
       <a:majorFont>
         <a:latin typeface="Public Sans"/>
         <a:ea typeface=""/>
@@ -18432,9 +18432,9 @@
 </file>
 
 <file path=ppt/theme/theme2.xml><?xml version="1.0" encoding="utf-8"?>
-<a:theme xmlns:a="http://schemas.openxmlformats.org/drawingml/2006/main" name="College Canteen Pre-Ordering Review">
+<a:theme xmlns:a="http://schemas.openxmlformats.org/drawingml/2006/main" name="College Canteen Pre-Ordering App Review">
   <a:themeElements>
-    <a:clrScheme name="College Canteen Pre-Ordering Review">
+    <a:clrScheme name="College Canteen Pre-Ordering App Review">
       <a:dk1>
         <a:srgbClr val="1F2430"/>
       </a:dk1>
@@ -18472,7 +18472,7 @@
         <a:srgbClr val="954F72"/>
       </a:folHlink>
     </a:clrScheme>
-    <a:fontScheme name="College Canteen Pre-Ordering Review">
+    <a:fontScheme name="College Canteen Pre-Ordering App Review">
       <a:majorFont>
         <a:latin typeface="Public Sans"/>
         <a:ea typeface=""/>

</xml_diff>